<commit_message>
name change and modal fix
</commit_message>
<xml_diff>
--- a/docs/presentations/How-It-Works-User-Guide.pptx
+++ b/docs/presentations/How-It-Works-User-Guide.pptx
@@ -3233,7 +3233,7 @@
                 <a:ea typeface="Calibri" pitchFamily="34" charset="-122"/>
                 <a:cs typeface="Calibri" pitchFamily="34" charset="-120"/>
               </a:rPr>
-              <a:t>A guide for accountants — what the system does, how branches and head office work,</a:t>
+              <a:t>A guide for accountants, what the system does, how branches and head office work,</a:t>
             </a:r>
             <a:endParaRPr lang="en-US" sz="1800" dirty="0"/>
           </a:p>
@@ -15573,7 +15573,7 @@
                 <a:ea typeface="Calibri" pitchFamily="34" charset="-122"/>
                 <a:cs typeface="Calibri" pitchFamily="34" charset="-120"/>
               </a:rPr>
-              <a:t>Every module updates the same books through the accounting engine —</a:t>
+              <a:t>Every module updates the same books through the accounting engine,</a:t>
             </a:r>
             <a:endParaRPr lang="en-US" sz="1800" dirty="0"/>
           </a:p>

</xml_diff>